<commit_message>
#73 slides: label slide 1's two-thirds figure as the post hoc check (narration unchanged; the video is recorded)
Refs #73

Co-Authored-By: Claude Opus 5.5 <noreply@anthropic.com>
</commit_message>
<xml_diff>
--- a/content/static/20261027-preregistered-mssp-early-renewal/video-slides.pptx
+++ b/content/static/20261027-preregistered-mssp-early-renewal/video-slides.pptx
@@ -3514,6 +3514,50 @@
               <a:t>Why?</a:t>
             </a:r>
             <a:endParaRPr lang="en-US" sz="6000" dirty="0"/>
+          </a:p>
+        </p:txBody>
+      </p:sp>
+      <p:sp>
+        <p:nvSpPr>
+          <p:cNvPr id="6" name="Text 4"/>
+          <p:cNvSpPr/>
+          <p:nvPr/>
+        </p:nvSpPr>
+        <p:spPr>
+          <a:xfrm>
+            <a:off x="812800" y="6238280"/>
+            <a:ext cx="10883392" cy="238720"/>
+          </a:xfrm>
+          <a:prstGeom prst="rect">
+            <a:avLst/>
+          </a:prstGeom>
+          <a:noFill/>
+          <a:ln/>
+        </p:spPr>
+        <p:txBody>
+          <a:bodyPr wrap="square" lIns="0" tIns="0" rIns="0" bIns="0" rtlCol="0" anchor="t">
+            <a:normAutofit/>
+          </a:bodyPr>
+          <a:lstStyle/>
+          <a:p>
+            <a:pPr algn="l" indent="0" marL="0">
+              <a:lnSpc>
+                <a:spcPts val="1680"/>
+              </a:lnSpc>
+              <a:buNone/>
+            </a:pPr>
+            <a:r>
+              <a:rPr lang="en-US" sz="1200" dirty="0">
+                <a:solidFill>
+                  <a:srgbClr val="C9D3DC"/>
+                </a:solidFill>
+                <a:latin typeface="Public Sans" pitchFamily="34" charset="0"/>
+                <a:ea typeface="Public Sans" pitchFamily="34" charset="-122"/>
+                <a:cs typeface="Public Sans" pitchFamily="34" charset="-120"/>
+              </a:rPr>
+              <a:t>Two-thirds: from a check made after the pre-registered analysis, against Medicare's published 2022 targets (slide 18).</a:t>
+            </a:r>
+            <a:endParaRPr lang="en-US" sz="1200" dirty="0"/>
           </a:p>
         </p:txBody>
       </p:sp>

</xml_diff>

<commit_message>
MSSP post: deck notes and transcript follow the video's re-recorded narration
Slides 1, 3, 6 and 22: the post hoc wording ("checked after the study", "By the later check"),
"A more difficult one.", "sales targets", "want to reset", "fifty percent". Images and PDF unchanged.

Co-Authored-By: Claude Opus 5.5 <noreply@anthropic.com>
</commit_message>
<xml_diff>
--- a/content/static/20261027-preregistered-mssp-early-renewal/video-slides.pptx
+++ b/content/static/20261027-preregistered-mssp-early-renewal/video-slides.pptx
@@ -534,7 +534,7 @@
           <a:p>
             <a:r>
               <a:rPr lang="en-US" dirty="0"/>
-              <a:t>[Clip 01] In January 2022, twenty-nine groups of doctors and hospitals did something odd. They quit their Medicare contracts early and signed new ones, which reset the targets Medicare uses to decide whether they earn a share of savings. Two thirds of them ended up with a lower target. A harder one. So why do it? I ran a study to find out, and I wrote down the rules before I looked at the data. Here's what I found.</a:t>
+              <a:t>[Clip 01] In January 2022, twenty-nine groups of doctors and hospitals did something odd. They quit their Medicare contracts early and signed new ones, which reset the targets Medicare uses to decide whether they earn a share of savings. By Medicare's own numbers, checked after the study, two thirds of them ended up with a lower target. A more difficult one. So why do it? I ran a study to find out, and I wrote down the rules before I looked at the data. Here's what I found.</a:t>
             </a:r>
             <a:endParaRPr lang="en-US" dirty="0"/>
           </a:p>
@@ -1766,7 +1766,7 @@
           <a:p>
             <a:r>
               <a:rPr lang="en-US" dirty="0"/>
-              <a:t>[Clip 22] So why did they hit reset? On average, not for a better target. Their targets mostly went down. But nearly all of them got the bigger share, and many were one step away. For a low-cost group that's already saving, keeping seventy-five percent instead of fifty can be worth more than a small drop in the target. That's my reading, not a tested result. But it fits how Medicare wrote the rules: if you wanted the bigger share mid-contract, a reset came with it.</a:t>
+              <a:t>[Clip 22] So why did they hit reset? On average, not for a better target. By the later check, their targets mostly went down. But nearly all of them got the bigger share, and many were one step away. For a low-cost group that's already saving, keeping seventy-five percent instead of fifty percent can be worth more than a small drop in the target. That's my reading, not a tested result. But it fits how Medicare wrote the rules: if you wanted the bigger share mid-contract, a reset came with it.</a:t>
             </a:r>
             <a:endParaRPr lang="en-US" dirty="0"/>
           </a:p>
@@ -2206,7 +2206,7 @@
           <a:p>
             <a:r>
               <a:rPr lang="en-US" dirty="0"/>
-              <a:t>[Clip 03] First, a familiar idea. Imagine your boss sets next year's sales target from what you sold this year. You crush it, and your reward is a harder target. Do too well today, and tomorrow gets tougher. Economists call this a ratchet, because it only clicks one way. Medicare has its own version of this, and it's the key to the whole puzzle.</a:t>
+              <a:t>[Clip 03] First, a familiar idea. Imagine your boss sets next year's sales targets from what you sold this year. You crush it, and your reward is a harder target. Do too well today, and tomorrow gets tougher. Economists call this a ratchet, because it only clicks one way. Medicare has its own version of this, and it's the key to the whole puzzle.</a:t>
             </a:r>
             <a:endParaRPr lang="en-US" dirty="0"/>
           </a:p>
@@ -2470,7 +2470,7 @@
           <a:p>
             <a:r>
               <a:rPr lang="en-US" dirty="0"/>
-              <a:t>[Clip 06] Now the catch. The target doesn't stay put. When a group signs a new contract, Medicare rebuilds the target, starting from the group's own recent spending. Our group spent ten thousand five hundred, so its new target starts there: five hundred dollars lower. Save money, and your next target gets harder. That's the ratchet. If that were the whole story, no successful group would ever want a reset. But there's a second part.</a:t>
+              <a:t>[Clip 06] Now the catch. The target doesn't stay put. When a group signs a new contract, Medicare rebuilds the target, starting from the group's own recent spending. Our group spent ten thousand five hundred, so its new target starts there: five hundred dollars lower. Save money, and your next target gets harder. That's the ratchet. If that were the whole story, no successful group would ever want to reset. But there's a second part.</a:t>
             </a:r>
             <a:endParaRPr lang="en-US" dirty="0"/>
           </a:p>

</xml_diff>